<commit_message>
MPower Report Template Phase 1 - fix placeholders visibility and background
</commit_message>
<xml_diff>
--- a/MPower_Report_Template_Phase1.pptx
+++ b/MPower_Report_Template_Phase1.pptx
@@ -142,10 +142,6 @@
           <a:prstGeom prst="rect">
             <a:avLst/>
           </a:prstGeom>
-          <a:noFill/>
-          <a:ln w="0">
-            <a:noFill/>
-          </a:ln>
         </p:spPr>
         <p:txBody>
           <a:bodyPr wrap="square" anchor="b"/>
@@ -185,10 +181,6 @@
           <a:prstGeom prst="rect">
             <a:avLst/>
           </a:prstGeom>
-          <a:noFill/>
-          <a:ln w="0">
-            <a:noFill/>
-          </a:ln>
         </p:spPr>
         <p:txBody>
           <a:bodyPr wrap="square" anchor="t"/>
@@ -228,10 +220,6 @@
           <a:prstGeom prst="rect">
             <a:avLst/>
           </a:prstGeom>
-          <a:noFill/>
-          <a:ln w="0">
-            <a:noFill/>
-          </a:ln>
         </p:spPr>
         <p:txBody>
           <a:bodyPr wrap="square" anchor="t"/>
@@ -274,11 +262,6 @@
           <a:solidFill>
             <a:srgbClr val="E5E7EB"/>
           </a:solidFill>
-          <a:ln w="1">
-            <a:solidFill>
-              <a:srgbClr val="E5E7EB"/>
-            </a:solidFill>
-          </a:ln>
         </p:spPr>
       </p:sp>
     </p:spTree>
@@ -327,10 +310,6 @@
           <a:prstGeom prst="rect">
             <a:avLst/>
           </a:prstGeom>
-          <a:noFill/>
-          <a:ln w="0">
-            <a:noFill/>
-          </a:ln>
         </p:spPr>
         <p:txBody>
           <a:bodyPr wrap="square" anchor="t"/>
@@ -370,10 +349,6 @@
           <a:prstGeom prst="rect">
             <a:avLst/>
           </a:prstGeom>
-          <a:noFill/>
-          <a:ln w="0">
-            <a:noFill/>
-          </a:ln>
         </p:spPr>
         <p:txBody>
           <a:bodyPr wrap="square" anchor="t"/>
@@ -413,10 +388,6 @@
           <a:prstGeom prst="rect">
             <a:avLst/>
           </a:prstGeom>
-          <a:noFill/>
-          <a:ln w="0">
-            <a:noFill/>
-          </a:ln>
         </p:spPr>
         <p:txBody>
           <a:bodyPr wrap="square" anchor="t"/>
@@ -456,10 +427,6 @@
           <a:prstGeom prst="rect">
             <a:avLst/>
           </a:prstGeom>
-          <a:noFill/>
-          <a:ln w="0">
-            <a:noFill/>
-          </a:ln>
         </p:spPr>
         <p:txBody>
           <a:bodyPr wrap="square" anchor="t"/>
@@ -499,10 +466,6 @@
           <a:prstGeom prst="rect">
             <a:avLst/>
           </a:prstGeom>
-          <a:noFill/>
-          <a:ln w="0">
-            <a:noFill/>
-          </a:ln>
         </p:spPr>
         <p:txBody>
           <a:bodyPr wrap="square" anchor="t"/>
@@ -542,10 +505,6 @@
           <a:prstGeom prst="rect">
             <a:avLst/>
           </a:prstGeom>
-          <a:noFill/>
-          <a:ln w="0">
-            <a:noFill/>
-          </a:ln>
         </p:spPr>
         <p:txBody>
           <a:bodyPr wrap="square" anchor="t"/>
@@ -585,10 +544,6 @@
           <a:prstGeom prst="rect">
             <a:avLst/>
           </a:prstGeom>
-          <a:noFill/>
-          <a:ln w="0">
-            <a:noFill/>
-          </a:ln>
         </p:spPr>
         <p:txBody>
           <a:bodyPr wrap="square" anchor="t"/>
@@ -628,10 +583,6 @@
           <a:prstGeom prst="rect">
             <a:avLst/>
           </a:prstGeom>
-          <a:noFill/>
-          <a:ln w="0">
-            <a:noFill/>
-          </a:ln>
         </p:spPr>
         <p:txBody>
           <a:bodyPr wrap="square" anchor="t"/>
@@ -699,10 +650,6 @@
           <a:prstGeom prst="rect">
             <a:avLst/>
           </a:prstGeom>
-          <a:noFill/>
-          <a:ln w="0">
-            <a:noFill/>
-          </a:ln>
         </p:spPr>
         <p:txBody>
           <a:bodyPr wrap="square" anchor="t"/>
@@ -742,10 +689,6 @@
           <a:prstGeom prst="rect">
             <a:avLst/>
           </a:prstGeom>
-          <a:noFill/>
-          <a:ln w="0">
-            <a:noFill/>
-          </a:ln>
         </p:spPr>
         <p:txBody>
           <a:bodyPr wrap="square" anchor="t"/>
@@ -785,10 +728,6 @@
           <a:prstGeom prst="rect">
             <a:avLst/>
           </a:prstGeom>
-          <a:noFill/>
-          <a:ln w="0">
-            <a:noFill/>
-          </a:ln>
         </p:spPr>
         <p:txBody>
           <a:bodyPr wrap="square" anchor="t"/>
@@ -828,10 +767,6 @@
           <a:prstGeom prst="rect">
             <a:avLst/>
           </a:prstGeom>
-          <a:noFill/>
-          <a:ln w="0">
-            <a:noFill/>
-          </a:ln>
         </p:spPr>
         <p:txBody>
           <a:bodyPr wrap="square" anchor="t"/>
@@ -871,10 +806,6 @@
           <a:prstGeom prst="rect">
             <a:avLst/>
           </a:prstGeom>
-          <a:noFill/>
-          <a:ln w="0">
-            <a:noFill/>
-          </a:ln>
         </p:spPr>
         <p:txBody>
           <a:bodyPr wrap="square" anchor="t"/>
@@ -914,10 +845,6 @@
           <a:prstGeom prst="rect">
             <a:avLst/>
           </a:prstGeom>
-          <a:noFill/>
-          <a:ln w="0">
-            <a:noFill/>
-          </a:ln>
         </p:spPr>
         <p:txBody>
           <a:bodyPr wrap="square" anchor="t"/>
@@ -957,10 +884,6 @@
           <a:prstGeom prst="rect">
             <a:avLst/>
           </a:prstGeom>
-          <a:noFill/>
-          <a:ln w="0">
-            <a:noFill/>
-          </a:ln>
         </p:spPr>
         <p:txBody>
           <a:bodyPr wrap="square" anchor="t"/>
@@ -1028,10 +951,6 @@
           <a:prstGeom prst="rect">
             <a:avLst/>
           </a:prstGeom>
-          <a:noFill/>
-          <a:ln w="0">
-            <a:noFill/>
-          </a:ln>
         </p:spPr>
         <p:txBody>
           <a:bodyPr wrap="square" anchor="t"/>
@@ -1071,10 +990,6 @@
           <a:prstGeom prst="rect">
             <a:avLst/>
           </a:prstGeom>
-          <a:noFill/>
-          <a:ln w="0">
-            <a:noFill/>
-          </a:ln>
         </p:spPr>
         <p:txBody>
           <a:bodyPr wrap="square" anchor="t"/>
@@ -1114,10 +1029,6 @@
           <a:prstGeom prst="rect">
             <a:avLst/>
           </a:prstGeom>
-          <a:noFill/>
-          <a:ln w="0">
-            <a:noFill/>
-          </a:ln>
         </p:spPr>
         <p:txBody>
           <a:bodyPr wrap="square" anchor="t"/>
@@ -1157,10 +1068,6 @@
           <a:prstGeom prst="rect">
             <a:avLst/>
           </a:prstGeom>
-          <a:noFill/>
-          <a:ln w="0">
-            <a:noFill/>
-          </a:ln>
         </p:spPr>
         <p:txBody>
           <a:bodyPr wrap="square" anchor="t"/>
@@ -1200,10 +1107,6 @@
           <a:prstGeom prst="rect">
             <a:avLst/>
           </a:prstGeom>
-          <a:noFill/>
-          <a:ln w="0">
-            <a:noFill/>
-          </a:ln>
         </p:spPr>
         <p:txBody>
           <a:bodyPr wrap="square" anchor="t"/>
@@ -1243,10 +1146,6 @@
           <a:prstGeom prst="rect">
             <a:avLst/>
           </a:prstGeom>
-          <a:noFill/>
-          <a:ln w="0">
-            <a:noFill/>
-          </a:ln>
         </p:spPr>
         <p:txBody>
           <a:bodyPr wrap="square" anchor="t"/>
@@ -1286,10 +1185,6 @@
           <a:prstGeom prst="rect">
             <a:avLst/>
           </a:prstGeom>
-          <a:noFill/>
-          <a:ln w="0">
-            <a:noFill/>
-          </a:ln>
         </p:spPr>
         <p:txBody>
           <a:bodyPr wrap="square" anchor="t"/>
@@ -1357,10 +1252,6 @@
           <a:prstGeom prst="rect">
             <a:avLst/>
           </a:prstGeom>
-          <a:noFill/>
-          <a:ln w="0">
-            <a:noFill/>
-          </a:ln>
         </p:spPr>
         <p:txBody>
           <a:bodyPr wrap="square" anchor="t"/>
@@ -1400,10 +1291,6 @@
           <a:prstGeom prst="rect">
             <a:avLst/>
           </a:prstGeom>
-          <a:noFill/>
-          <a:ln w="0">
-            <a:noFill/>
-          </a:ln>
         </p:spPr>
         <p:txBody>
           <a:bodyPr wrap="square" anchor="t"/>
@@ -1443,10 +1330,6 @@
           <a:prstGeom prst="rect">
             <a:avLst/>
           </a:prstGeom>
-          <a:noFill/>
-          <a:ln w="0">
-            <a:noFill/>
-          </a:ln>
         </p:spPr>
         <p:txBody>
           <a:bodyPr wrap="square" anchor="t"/>
@@ -1489,11 +1372,6 @@
           <a:solidFill>
             <a:srgbClr val="F3F4F6"/>
           </a:solidFill>
-          <a:ln w="1">
-            <a:solidFill>
-              <a:srgbClr val="E5E7EB"/>
-            </a:solidFill>
-          </a:ln>
         </p:spPr>
       </p:sp>
       <p:sp>
@@ -1514,10 +1392,6 @@
           <a:prstGeom prst="rect">
             <a:avLst/>
           </a:prstGeom>
-          <a:noFill/>
-          <a:ln w="0">
-            <a:noFill/>
-          </a:ln>
         </p:spPr>
         <p:txBody>
           <a:bodyPr wrap="square" anchor="t"/>
@@ -1557,10 +1431,6 @@
           <a:prstGeom prst="rect">
             <a:avLst/>
           </a:prstGeom>
-          <a:noFill/>
-          <a:ln w="0">
-            <a:noFill/>
-          </a:ln>
         </p:spPr>
         <p:txBody>
           <a:bodyPr wrap="square" anchor="t"/>
@@ -1600,10 +1470,6 @@
           <a:prstGeom prst="rect">
             <a:avLst/>
           </a:prstGeom>
-          <a:noFill/>
-          <a:ln w="0">
-            <a:noFill/>
-          </a:ln>
         </p:spPr>
         <p:txBody>
           <a:bodyPr wrap="square" anchor="t"/>
@@ -1643,10 +1509,6 @@
           <a:prstGeom prst="rect">
             <a:avLst/>
           </a:prstGeom>
-          <a:noFill/>
-          <a:ln w="0">
-            <a:noFill/>
-          </a:ln>
         </p:spPr>
         <p:txBody>
           <a:bodyPr wrap="square" anchor="t"/>
@@ -1714,10 +1576,6 @@
           <a:prstGeom prst="rect">
             <a:avLst/>
           </a:prstGeom>
-          <a:noFill/>
-          <a:ln w="0">
-            <a:noFill/>
-          </a:ln>
         </p:spPr>
         <p:txBody>
           <a:bodyPr wrap="square" anchor="t"/>
@@ -1757,10 +1615,6 @@
           <a:prstGeom prst="rect">
             <a:avLst/>
           </a:prstGeom>
-          <a:noFill/>
-          <a:ln w="0">
-            <a:noFill/>
-          </a:ln>
         </p:spPr>
         <p:txBody>
           <a:bodyPr wrap="square" anchor="t"/>
@@ -1800,10 +1654,6 @@
           <a:prstGeom prst="rect">
             <a:avLst/>
           </a:prstGeom>
-          <a:noFill/>
-          <a:ln w="0">
-            <a:noFill/>
-          </a:ln>
         </p:spPr>
         <p:txBody>
           <a:bodyPr wrap="square" anchor="t"/>
@@ -1846,11 +1696,6 @@
           <a:solidFill>
             <a:srgbClr val="F3F4F6"/>
           </a:solidFill>
-          <a:ln w="1">
-            <a:solidFill>
-              <a:srgbClr val="E5E7EB"/>
-            </a:solidFill>
-          </a:ln>
         </p:spPr>
       </p:sp>
       <p:sp>
@@ -1871,10 +1716,6 @@
           <a:prstGeom prst="rect">
             <a:avLst/>
           </a:prstGeom>
-          <a:noFill/>
-          <a:ln w="0">
-            <a:noFill/>
-          </a:ln>
         </p:spPr>
         <p:txBody>
           <a:bodyPr wrap="square" anchor="t"/>
@@ -1914,10 +1755,6 @@
           <a:prstGeom prst="rect">
             <a:avLst/>
           </a:prstGeom>
-          <a:noFill/>
-          <a:ln w="0">
-            <a:noFill/>
-          </a:ln>
         </p:spPr>
         <p:txBody>
           <a:bodyPr wrap="square" anchor="t"/>
@@ -1957,10 +1794,6 @@
           <a:prstGeom prst="rect">
             <a:avLst/>
           </a:prstGeom>
-          <a:noFill/>
-          <a:ln w="0">
-            <a:noFill/>
-          </a:ln>
         </p:spPr>
         <p:txBody>
           <a:bodyPr wrap="square" anchor="t"/>
@@ -2028,10 +1861,6 @@
           <a:prstGeom prst="rect">
             <a:avLst/>
           </a:prstGeom>
-          <a:noFill/>
-          <a:ln w="0">
-            <a:noFill/>
-          </a:ln>
         </p:spPr>
         <p:txBody>
           <a:bodyPr wrap="square" anchor="t"/>
@@ -2071,10 +1900,6 @@
           <a:prstGeom prst="rect">
             <a:avLst/>
           </a:prstGeom>
-          <a:noFill/>
-          <a:ln w="0">
-            <a:noFill/>
-          </a:ln>
         </p:spPr>
         <p:txBody>
           <a:bodyPr wrap="square" anchor="t"/>
@@ -2114,10 +1939,6 @@
           <a:prstGeom prst="rect">
             <a:avLst/>
           </a:prstGeom>
-          <a:noFill/>
-          <a:ln w="0">
-            <a:noFill/>
-          </a:ln>
         </p:spPr>
         <p:txBody>
           <a:bodyPr wrap="square" anchor="t"/>
@@ -2157,10 +1978,6 @@
           <a:prstGeom prst="rect">
             <a:avLst/>
           </a:prstGeom>
-          <a:noFill/>
-          <a:ln w="0">
-            <a:noFill/>
-          </a:ln>
         </p:spPr>
         <p:txBody>
           <a:bodyPr wrap="square" anchor="t"/>
@@ -2200,10 +2017,6 @@
           <a:prstGeom prst="rect">
             <a:avLst/>
           </a:prstGeom>
-          <a:noFill/>
-          <a:ln w="0">
-            <a:noFill/>
-          </a:ln>
         </p:spPr>
         <p:txBody>
           <a:bodyPr wrap="square" anchor="t"/>
@@ -2243,10 +2056,6 @@
           <a:prstGeom prst="rect">
             <a:avLst/>
           </a:prstGeom>
-          <a:noFill/>
-          <a:ln w="0">
-            <a:noFill/>
-          </a:ln>
         </p:spPr>
         <p:txBody>
           <a:bodyPr wrap="square" anchor="t"/>
@@ -2286,10 +2095,6 @@
           <a:prstGeom prst="rect">
             <a:avLst/>
           </a:prstGeom>
-          <a:noFill/>
-          <a:ln w="0">
-            <a:noFill/>
-          </a:ln>
         </p:spPr>
         <p:txBody>
           <a:bodyPr wrap="square" anchor="t"/>
@@ -2329,10 +2134,6 @@
           <a:prstGeom prst="rect">
             <a:avLst/>
           </a:prstGeom>
-          <a:noFill/>
-          <a:ln w="0">
-            <a:noFill/>
-          </a:ln>
         </p:spPr>
         <p:txBody>
           <a:bodyPr wrap="square" anchor="t"/>
@@ -2400,10 +2201,6 @@
           <a:prstGeom prst="rect">
             <a:avLst/>
           </a:prstGeom>
-          <a:noFill/>
-          <a:ln w="0">
-            <a:noFill/>
-          </a:ln>
         </p:spPr>
         <p:txBody>
           <a:bodyPr wrap="square" anchor="t"/>
@@ -2443,10 +2240,6 @@
           <a:prstGeom prst="rect">
             <a:avLst/>
           </a:prstGeom>
-          <a:noFill/>
-          <a:ln w="0">
-            <a:noFill/>
-          </a:ln>
         </p:spPr>
         <p:txBody>
           <a:bodyPr wrap="square" anchor="t"/>
@@ -2486,10 +2279,6 @@
           <a:prstGeom prst="rect">
             <a:avLst/>
           </a:prstGeom>
-          <a:noFill/>
-          <a:ln w="0">
-            <a:noFill/>
-          </a:ln>
         </p:spPr>
         <p:txBody>
           <a:bodyPr wrap="square" anchor="t"/>
@@ -2532,11 +2321,6 @@
           <a:solidFill>
             <a:srgbClr val="F3F4F6"/>
           </a:solidFill>
-          <a:ln w="1">
-            <a:solidFill>
-              <a:srgbClr val="E5E7EB"/>
-            </a:solidFill>
-          </a:ln>
         </p:spPr>
       </p:sp>
       <p:sp>
@@ -2557,10 +2341,6 @@
           <a:prstGeom prst="rect">
             <a:avLst/>
           </a:prstGeom>
-          <a:noFill/>
-          <a:ln w="0">
-            <a:noFill/>
-          </a:ln>
         </p:spPr>
         <p:txBody>
           <a:bodyPr wrap="square" anchor="t"/>
@@ -2600,10 +2380,6 @@
           <a:prstGeom prst="rect">
             <a:avLst/>
           </a:prstGeom>
-          <a:noFill/>
-          <a:ln w="0">
-            <a:noFill/>
-          </a:ln>
         </p:spPr>
         <p:txBody>
           <a:bodyPr wrap="square" anchor="t"/>
@@ -2643,10 +2419,6 @@
           <a:prstGeom prst="rect">
             <a:avLst/>
           </a:prstGeom>
-          <a:noFill/>
-          <a:ln w="0">
-            <a:noFill/>
-          </a:ln>
         </p:spPr>
         <p:txBody>
           <a:bodyPr wrap="square" anchor="t"/>
@@ -2714,10 +2486,6 @@
           <a:prstGeom prst="rect">
             <a:avLst/>
           </a:prstGeom>
-          <a:noFill/>
-          <a:ln w="0">
-            <a:noFill/>
-          </a:ln>
         </p:spPr>
         <p:txBody>
           <a:bodyPr wrap="square" anchor="t"/>
@@ -2757,10 +2525,6 @@
           <a:prstGeom prst="rect">
             <a:avLst/>
           </a:prstGeom>
-          <a:noFill/>
-          <a:ln w="0">
-            <a:noFill/>
-          </a:ln>
         </p:spPr>
         <p:txBody>
           <a:bodyPr wrap="square" anchor="t"/>
@@ -2800,10 +2564,6 @@
           <a:prstGeom prst="rect">
             <a:avLst/>
           </a:prstGeom>
-          <a:noFill/>
-          <a:ln w="0">
-            <a:noFill/>
-          </a:ln>
         </p:spPr>
         <p:txBody>
           <a:bodyPr wrap="square" anchor="t"/>
@@ -2846,11 +2606,6 @@
           <a:solidFill>
             <a:srgbClr val="F3F4F6"/>
           </a:solidFill>
-          <a:ln w="1">
-            <a:solidFill>
-              <a:srgbClr val="E5E7EB"/>
-            </a:solidFill>
-          </a:ln>
         </p:spPr>
       </p:sp>
       <p:sp>
@@ -2871,10 +2626,6 @@
           <a:prstGeom prst="rect">
             <a:avLst/>
           </a:prstGeom>
-          <a:noFill/>
-          <a:ln w="0">
-            <a:noFill/>
-          </a:ln>
         </p:spPr>
         <p:txBody>
           <a:bodyPr wrap="square" anchor="t"/>
@@ -2914,10 +2665,6 @@
           <a:prstGeom prst="rect">
             <a:avLst/>
           </a:prstGeom>
-          <a:noFill/>
-          <a:ln w="0">
-            <a:noFill/>
-          </a:ln>
         </p:spPr>
         <p:txBody>
           <a:bodyPr wrap="square" anchor="t"/>
@@ -2957,10 +2704,6 @@
           <a:prstGeom prst="rect">
             <a:avLst/>
           </a:prstGeom>
-          <a:noFill/>
-          <a:ln w="0">
-            <a:noFill/>
-          </a:ln>
         </p:spPr>
         <p:txBody>
           <a:bodyPr wrap="square" anchor="t"/>
@@ -3028,10 +2771,6 @@
           <a:prstGeom prst="rect">
             <a:avLst/>
           </a:prstGeom>
-          <a:noFill/>
-          <a:ln w="0">
-            <a:noFill/>
-          </a:ln>
         </p:spPr>
         <p:txBody>
           <a:bodyPr wrap="square" anchor="t"/>
@@ -3071,10 +2810,6 @@
           <a:prstGeom prst="rect">
             <a:avLst/>
           </a:prstGeom>
-          <a:noFill/>
-          <a:ln w="0">
-            <a:noFill/>
-          </a:ln>
         </p:spPr>
         <p:txBody>
           <a:bodyPr wrap="square" anchor="t"/>
@@ -3114,10 +2849,6 @@
           <a:prstGeom prst="rect">
             <a:avLst/>
           </a:prstGeom>
-          <a:noFill/>
-          <a:ln w="0">
-            <a:noFill/>
-          </a:ln>
         </p:spPr>
         <p:txBody>
           <a:bodyPr wrap="square" anchor="t"/>
@@ -3160,11 +2891,6 @@
           <a:solidFill>
             <a:srgbClr val="F3F4F6"/>
           </a:solidFill>
-          <a:ln w="1">
-            <a:solidFill>
-              <a:srgbClr val="E5E7EB"/>
-            </a:solidFill>
-          </a:ln>
         </p:spPr>
       </p:sp>
     </p:spTree>
@@ -3213,10 +2939,6 @@
           <a:prstGeom prst="rect">
             <a:avLst/>
           </a:prstGeom>
-          <a:noFill/>
-          <a:ln w="0">
-            <a:noFill/>
-          </a:ln>
         </p:spPr>
         <p:txBody>
           <a:bodyPr wrap="square" anchor="t"/>
@@ -3256,10 +2978,6 @@
           <a:prstGeom prst="rect">
             <a:avLst/>
           </a:prstGeom>
-          <a:noFill/>
-          <a:ln w="0">
-            <a:noFill/>
-          </a:ln>
         </p:spPr>
         <p:txBody>
           <a:bodyPr wrap="square" anchor="t"/>
@@ -3299,10 +3017,6 @@
           <a:prstGeom prst="rect">
             <a:avLst/>
           </a:prstGeom>
-          <a:noFill/>
-          <a:ln w="0">
-            <a:noFill/>
-          </a:ln>
         </p:spPr>
         <p:txBody>
           <a:bodyPr wrap="square" anchor="t"/>
@@ -3342,10 +3056,6 @@
           <a:prstGeom prst="rect">
             <a:avLst/>
           </a:prstGeom>
-          <a:noFill/>
-          <a:ln w="0">
-            <a:noFill/>
-          </a:ln>
         </p:spPr>
         <p:txBody>
           <a:bodyPr wrap="square" anchor="t"/>
@@ -3385,10 +3095,6 @@
           <a:prstGeom prst="rect">
             <a:avLst/>
           </a:prstGeom>
-          <a:noFill/>
-          <a:ln w="0">
-            <a:noFill/>
-          </a:ln>
         </p:spPr>
         <p:txBody>
           <a:bodyPr wrap="square" anchor="t"/>
@@ -3428,10 +3134,6 @@
           <a:prstGeom prst="rect">
             <a:avLst/>
           </a:prstGeom>
-          <a:noFill/>
-          <a:ln w="0">
-            <a:noFill/>
-          </a:ln>
         </p:spPr>
         <p:txBody>
           <a:bodyPr wrap="square" anchor="t"/>
@@ -3471,10 +3173,6 @@
           <a:prstGeom prst="rect">
             <a:avLst/>
           </a:prstGeom>
-          <a:noFill/>
-          <a:ln w="0">
-            <a:noFill/>
-          </a:ln>
         </p:spPr>
         <p:txBody>
           <a:bodyPr wrap="square" anchor="t"/>
@@ -3514,10 +3212,6 @@
           <a:prstGeom prst="rect">
             <a:avLst/>
           </a:prstGeom>
-          <a:noFill/>
-          <a:ln w="0">
-            <a:noFill/>
-          </a:ln>
         </p:spPr>
         <p:txBody>
           <a:bodyPr wrap="square" anchor="t"/>
@@ -3557,10 +3251,6 @@
           <a:prstGeom prst="rect">
             <a:avLst/>
           </a:prstGeom>
-          <a:noFill/>
-          <a:ln w="0">
-            <a:noFill/>
-          </a:ln>
         </p:spPr>
         <p:txBody>
           <a:bodyPr wrap="square" anchor="t"/>
@@ -3628,10 +3318,6 @@
           <a:prstGeom prst="rect">
             <a:avLst/>
           </a:prstGeom>
-          <a:noFill/>
-          <a:ln w="0">
-            <a:noFill/>
-          </a:ln>
         </p:spPr>
         <p:txBody>
           <a:bodyPr wrap="square" anchor="t"/>
@@ -3671,10 +3357,6 @@
           <a:prstGeom prst="rect">
             <a:avLst/>
           </a:prstGeom>
-          <a:noFill/>
-          <a:ln w="0">
-            <a:noFill/>
-          </a:ln>
         </p:spPr>
         <p:txBody>
           <a:bodyPr wrap="square" anchor="t"/>
@@ -3742,10 +3424,6 @@
           <a:prstGeom prst="rect">
             <a:avLst/>
           </a:prstGeom>
-          <a:noFill/>
-          <a:ln w="0">
-            <a:noFill/>
-          </a:ln>
         </p:spPr>
         <p:txBody>
           <a:bodyPr wrap="square" anchor="t"/>
@@ -3785,10 +3463,6 @@
           <a:prstGeom prst="rect">
             <a:avLst/>
           </a:prstGeom>
-          <a:noFill/>
-          <a:ln w="0">
-            <a:noFill/>
-          </a:ln>
         </p:spPr>
         <p:txBody>
           <a:bodyPr wrap="square" anchor="t"/>
@@ -3828,10 +3502,6 @@
           <a:prstGeom prst="rect">
             <a:avLst/>
           </a:prstGeom>
-          <a:noFill/>
-          <a:ln w="0">
-            <a:noFill/>
-          </a:ln>
         </p:spPr>
         <p:txBody>
           <a:bodyPr wrap="square" anchor="t"/>
@@ -3871,10 +3541,6 @@
           <a:prstGeom prst="rect">
             <a:avLst/>
           </a:prstGeom>
-          <a:noFill/>
-          <a:ln w="0">
-            <a:noFill/>
-          </a:ln>
         </p:spPr>
         <p:txBody>
           <a:bodyPr wrap="square" anchor="t"/>
@@ -3914,10 +3580,6 @@
           <a:prstGeom prst="rect">
             <a:avLst/>
           </a:prstGeom>
-          <a:noFill/>
-          <a:ln w="0">
-            <a:noFill/>
-          </a:ln>
         </p:spPr>
         <p:txBody>
           <a:bodyPr wrap="square" anchor="t"/>
@@ -3957,10 +3619,6 @@
           <a:prstGeom prst="rect">
             <a:avLst/>
           </a:prstGeom>
-          <a:noFill/>
-          <a:ln w="0">
-            <a:noFill/>
-          </a:ln>
         </p:spPr>
         <p:txBody>
           <a:bodyPr wrap="square" anchor="t"/>
@@ -4000,10 +3658,6 @@
           <a:prstGeom prst="rect">
             <a:avLst/>
           </a:prstGeom>
-          <a:noFill/>
-          <a:ln w="0">
-            <a:noFill/>
-          </a:ln>
         </p:spPr>
         <p:txBody>
           <a:bodyPr wrap="square" anchor="t"/>
@@ -4043,10 +3697,6 @@
           <a:prstGeom prst="rect">
             <a:avLst/>
           </a:prstGeom>
-          <a:noFill/>
-          <a:ln w="0">
-            <a:noFill/>
-          </a:ln>
         </p:spPr>
         <p:txBody>
           <a:bodyPr wrap="square" anchor="t"/>
@@ -4114,10 +3764,6 @@
           <a:prstGeom prst="rect">
             <a:avLst/>
           </a:prstGeom>
-          <a:noFill/>
-          <a:ln w="0">
-            <a:noFill/>
-          </a:ln>
         </p:spPr>
         <p:txBody>
           <a:bodyPr wrap="square" anchor="t"/>
@@ -4157,10 +3803,6 @@
           <a:prstGeom prst="rect">
             <a:avLst/>
           </a:prstGeom>
-          <a:noFill/>
-          <a:ln w="0">
-            <a:noFill/>
-          </a:ln>
         </p:spPr>
         <p:txBody>
           <a:bodyPr wrap="square" anchor="t"/>
@@ -4200,10 +3842,6 @@
           <a:prstGeom prst="rect">
             <a:avLst/>
           </a:prstGeom>
-          <a:noFill/>
-          <a:ln w="0">
-            <a:noFill/>
-          </a:ln>
         </p:spPr>
         <p:txBody>
           <a:bodyPr wrap="square" anchor="t"/>
@@ -4243,10 +3881,6 @@
           <a:prstGeom prst="rect">
             <a:avLst/>
           </a:prstGeom>
-          <a:noFill/>
-          <a:ln w="0">
-            <a:noFill/>
-          </a:ln>
         </p:spPr>
         <p:txBody>
           <a:bodyPr wrap="square" anchor="t"/>
@@ -4286,10 +3920,6 @@
           <a:prstGeom prst="rect">
             <a:avLst/>
           </a:prstGeom>
-          <a:noFill/>
-          <a:ln w="0">
-            <a:noFill/>
-          </a:ln>
         </p:spPr>
         <p:txBody>
           <a:bodyPr wrap="square" anchor="t"/>
@@ -4329,10 +3959,6 @@
           <a:prstGeom prst="rect">
             <a:avLst/>
           </a:prstGeom>
-          <a:noFill/>
-          <a:ln w="0">
-            <a:noFill/>
-          </a:ln>
         </p:spPr>
         <p:txBody>
           <a:bodyPr wrap="square" anchor="t"/>
@@ -4372,10 +3998,6 @@
           <a:prstGeom prst="rect">
             <a:avLst/>
           </a:prstGeom>
-          <a:noFill/>
-          <a:ln w="0">
-            <a:noFill/>
-          </a:ln>
         </p:spPr>
         <p:txBody>
           <a:bodyPr wrap="square" anchor="t"/>
@@ -4415,10 +4037,6 @@
           <a:prstGeom prst="rect">
             <a:avLst/>
           </a:prstGeom>
-          <a:noFill/>
-          <a:ln w="0">
-            <a:noFill/>
-          </a:ln>
         </p:spPr>
         <p:txBody>
           <a:bodyPr wrap="square" anchor="t"/>
@@ -4486,10 +4104,6 @@
           <a:prstGeom prst="rect">
             <a:avLst/>
           </a:prstGeom>
-          <a:noFill/>
-          <a:ln w="0">
-            <a:noFill/>
-          </a:ln>
         </p:spPr>
         <p:txBody>
           <a:bodyPr wrap="square" anchor="t"/>
@@ -4529,10 +4143,6 @@
           <a:prstGeom prst="rect">
             <a:avLst/>
           </a:prstGeom>
-          <a:noFill/>
-          <a:ln w="0">
-            <a:noFill/>
-          </a:ln>
         </p:spPr>
         <p:txBody>
           <a:bodyPr wrap="square" anchor="t"/>
@@ -4572,10 +4182,6 @@
           <a:prstGeom prst="rect">
             <a:avLst/>
           </a:prstGeom>
-          <a:noFill/>
-          <a:ln w="0">
-            <a:noFill/>
-          </a:ln>
         </p:spPr>
         <p:txBody>
           <a:bodyPr wrap="square" anchor="t"/>
@@ -4615,10 +4221,6 @@
           <a:prstGeom prst="rect">
             <a:avLst/>
           </a:prstGeom>
-          <a:noFill/>
-          <a:ln w="0">
-            <a:noFill/>
-          </a:ln>
         </p:spPr>
         <p:txBody>
           <a:bodyPr wrap="square" anchor="t"/>
@@ -4658,10 +4260,6 @@
           <a:prstGeom prst="rect">
             <a:avLst/>
           </a:prstGeom>
-          <a:noFill/>
-          <a:ln w="0">
-            <a:noFill/>
-          </a:ln>
         </p:spPr>
         <p:txBody>
           <a:bodyPr wrap="square" anchor="t"/>
@@ -4701,10 +4299,6 @@
           <a:prstGeom prst="rect">
             <a:avLst/>
           </a:prstGeom>
-          <a:noFill/>
-          <a:ln w="0">
-            <a:noFill/>
-          </a:ln>
         </p:spPr>
         <p:txBody>
           <a:bodyPr wrap="square" anchor="t"/>
@@ -4744,10 +4338,6 @@
           <a:prstGeom prst="rect">
             <a:avLst/>
           </a:prstGeom>
-          <a:noFill/>
-          <a:ln w="0">
-            <a:noFill/>
-          </a:ln>
         </p:spPr>
         <p:txBody>
           <a:bodyPr wrap="square" anchor="t"/>
@@ -4787,10 +4377,6 @@
           <a:prstGeom prst="rect">
             <a:avLst/>
           </a:prstGeom>
-          <a:noFill/>
-          <a:ln w="0">
-            <a:noFill/>
-          </a:ln>
         </p:spPr>
         <p:txBody>
           <a:bodyPr wrap="square" anchor="t"/>
@@ -4830,10 +4416,6 @@
           <a:prstGeom prst="rect">
             <a:avLst/>
           </a:prstGeom>
-          <a:noFill/>
-          <a:ln w="0">
-            <a:noFill/>
-          </a:ln>
         </p:spPr>
         <p:txBody>
           <a:bodyPr wrap="square" anchor="t"/>
@@ -4901,10 +4483,6 @@
           <a:prstGeom prst="rect">
             <a:avLst/>
           </a:prstGeom>
-          <a:noFill/>
-          <a:ln w="0">
-            <a:noFill/>
-          </a:ln>
         </p:spPr>
         <p:txBody>
           <a:bodyPr wrap="square" anchor="t"/>
@@ -4944,10 +4522,6 @@
           <a:prstGeom prst="rect">
             <a:avLst/>
           </a:prstGeom>
-          <a:noFill/>
-          <a:ln w="0">
-            <a:noFill/>
-          </a:ln>
         </p:spPr>
         <p:txBody>
           <a:bodyPr wrap="square" anchor="t"/>
@@ -4987,10 +4561,6 @@
           <a:prstGeom prst="rect">
             <a:avLst/>
           </a:prstGeom>
-          <a:noFill/>
-          <a:ln w="0">
-            <a:noFill/>
-          </a:ln>
         </p:spPr>
         <p:txBody>
           <a:bodyPr wrap="square" anchor="t"/>
@@ -5030,10 +4600,6 @@
           <a:prstGeom prst="rect">
             <a:avLst/>
           </a:prstGeom>
-          <a:noFill/>
-          <a:ln w="0">
-            <a:noFill/>
-          </a:ln>
         </p:spPr>
         <p:txBody>
           <a:bodyPr wrap="square" anchor="t"/>
@@ -5076,11 +4642,6 @@
           <a:solidFill>
             <a:srgbClr val="E5E7EB"/>
           </a:solidFill>
-          <a:ln w="1">
-            <a:solidFill>
-              <a:srgbClr val="E5E7EB"/>
-            </a:solidFill>
-          </a:ln>
         </p:spPr>
       </p:sp>
       <p:sp>
@@ -5101,10 +4662,6 @@
           <a:prstGeom prst="rect">
             <a:avLst/>
           </a:prstGeom>
-          <a:noFill/>
-          <a:ln w="0">
-            <a:noFill/>
-          </a:ln>
         </p:spPr>
         <p:txBody>
           <a:bodyPr wrap="square" anchor="t"/>
@@ -5144,10 +4701,6 @@
           <a:prstGeom prst="rect">
             <a:avLst/>
           </a:prstGeom>
-          <a:noFill/>
-          <a:ln w="0">
-            <a:noFill/>
-          </a:ln>
         </p:spPr>
         <p:txBody>
           <a:bodyPr wrap="square" anchor="t"/>
@@ -5215,10 +4768,6 @@
           <a:prstGeom prst="rect">
             <a:avLst/>
           </a:prstGeom>
-          <a:noFill/>
-          <a:ln w="0">
-            <a:noFill/>
-          </a:ln>
         </p:spPr>
         <p:txBody>
           <a:bodyPr wrap="square" anchor="t"/>
@@ -5261,11 +4810,6 @@
           <a:solidFill>
             <a:srgbClr val="F3F4F6"/>
           </a:solidFill>
-          <a:ln w="1">
-            <a:solidFill>
-              <a:srgbClr val="E5E7EB"/>
-            </a:solidFill>
-          </a:ln>
         </p:spPr>
       </p:sp>
     </p:spTree>
@@ -5314,10 +4858,6 @@
           <a:prstGeom prst="rect">
             <a:avLst/>
           </a:prstGeom>
-          <a:noFill/>
-          <a:ln w="0">
-            <a:noFill/>
-          </a:ln>
         </p:spPr>
         <p:txBody>
           <a:bodyPr wrap="square" anchor="t"/>
@@ -5357,10 +4897,6 @@
           <a:prstGeom prst="rect">
             <a:avLst/>
           </a:prstGeom>
-          <a:noFill/>
-          <a:ln w="0">
-            <a:noFill/>
-          </a:ln>
         </p:spPr>
         <p:txBody>
           <a:bodyPr wrap="square" anchor="t"/>
@@ -5400,10 +4936,6 @@
           <a:prstGeom prst="rect">
             <a:avLst/>
           </a:prstGeom>
-          <a:noFill/>
-          <a:ln w="0">
-            <a:noFill/>
-          </a:ln>
         </p:spPr>
         <p:txBody>
           <a:bodyPr wrap="square" anchor="t"/>
@@ -5446,11 +4978,6 @@
           <a:solidFill>
             <a:srgbClr val="F3F4F6"/>
           </a:solidFill>
-          <a:ln w="1">
-            <a:solidFill>
-              <a:srgbClr val="E5E7EB"/>
-            </a:solidFill>
-          </a:ln>
         </p:spPr>
       </p:sp>
     </p:spTree>
@@ -5499,10 +5026,6 @@
           <a:prstGeom prst="rect">
             <a:avLst/>
           </a:prstGeom>
-          <a:noFill/>
-          <a:ln w="0">
-            <a:noFill/>
-          </a:ln>
         </p:spPr>
         <p:txBody>
           <a:bodyPr wrap="square" anchor="t"/>
@@ -5542,10 +5065,6 @@
           <a:prstGeom prst="rect">
             <a:avLst/>
           </a:prstGeom>
-          <a:noFill/>
-          <a:ln w="0">
-            <a:noFill/>
-          </a:ln>
         </p:spPr>
         <p:txBody>
           <a:bodyPr wrap="square" anchor="t"/>
@@ -5585,10 +5104,6 @@
           <a:prstGeom prst="rect">
             <a:avLst/>
           </a:prstGeom>
-          <a:noFill/>
-          <a:ln w="0">
-            <a:noFill/>
-          </a:ln>
         </p:spPr>
         <p:txBody>
           <a:bodyPr wrap="square" anchor="t"/>
@@ -5631,11 +5146,6 @@
           <a:solidFill>
             <a:srgbClr val="F3F4F6"/>
           </a:solidFill>
-          <a:ln w="1">
-            <a:solidFill>
-              <a:srgbClr val="E5E7EB"/>
-            </a:solidFill>
-          </a:ln>
         </p:spPr>
       </p:sp>
     </p:spTree>
@@ -5684,10 +5194,6 @@
           <a:prstGeom prst="rect">
             <a:avLst/>
           </a:prstGeom>
-          <a:noFill/>
-          <a:ln w="0">
-            <a:noFill/>
-          </a:ln>
         </p:spPr>
         <p:txBody>
           <a:bodyPr wrap="square" anchor="t"/>
@@ -5730,11 +5236,6 @@
           <a:solidFill>
             <a:srgbClr val="F3F4F6"/>
           </a:solidFill>
-          <a:ln w="1">
-            <a:solidFill>
-              <a:srgbClr val="E5E7EB"/>
-            </a:solidFill>
-          </a:ln>
         </p:spPr>
       </p:sp>
     </p:spTree>
@@ -5783,10 +5284,6 @@
           <a:prstGeom prst="rect">
             <a:avLst/>
           </a:prstGeom>
-          <a:noFill/>
-          <a:ln w="0">
-            <a:noFill/>
-          </a:ln>
         </p:spPr>
         <p:txBody>
           <a:bodyPr wrap="square" anchor="t"/>
@@ -5826,10 +5323,6 @@
           <a:prstGeom prst="rect">
             <a:avLst/>
           </a:prstGeom>
-          <a:noFill/>
-          <a:ln w="0">
-            <a:noFill/>
-          </a:ln>
         </p:spPr>
         <p:txBody>
           <a:bodyPr wrap="square" anchor="t"/>
@@ -5869,10 +5362,6 @@
           <a:prstGeom prst="rect">
             <a:avLst/>
           </a:prstGeom>
-          <a:noFill/>
-          <a:ln w="0">
-            <a:noFill/>
-          </a:ln>
         </p:spPr>
         <p:txBody>
           <a:bodyPr wrap="square" anchor="t"/>
@@ -5915,11 +5404,6 @@
           <a:solidFill>
             <a:srgbClr val="F3F4F6"/>
           </a:solidFill>
-          <a:ln w="1">
-            <a:solidFill>
-              <a:srgbClr val="E5E7EB"/>
-            </a:solidFill>
-          </a:ln>
         </p:spPr>
       </p:sp>
     </p:spTree>
@@ -5968,10 +5452,6 @@
           <a:prstGeom prst="rect">
             <a:avLst/>
           </a:prstGeom>
-          <a:noFill/>
-          <a:ln w="0">
-            <a:noFill/>
-          </a:ln>
         </p:spPr>
         <p:txBody>
           <a:bodyPr wrap="square" anchor="t"/>
@@ -6011,10 +5491,6 @@
           <a:prstGeom prst="rect">
             <a:avLst/>
           </a:prstGeom>
-          <a:noFill/>
-          <a:ln w="0">
-            <a:noFill/>
-          </a:ln>
         </p:spPr>
         <p:txBody>
           <a:bodyPr wrap="square" anchor="t"/>
@@ -6054,10 +5530,6 @@
           <a:prstGeom prst="rect">
             <a:avLst/>
           </a:prstGeom>
-          <a:noFill/>
-          <a:ln w="0">
-            <a:noFill/>
-          </a:ln>
         </p:spPr>
         <p:txBody>
           <a:bodyPr wrap="square" anchor="t"/>
@@ -6100,11 +5572,6 @@
           <a:solidFill>
             <a:srgbClr val="F3F4F6"/>
           </a:solidFill>
-          <a:ln w="1">
-            <a:solidFill>
-              <a:srgbClr val="E5E7EB"/>
-            </a:solidFill>
-          </a:ln>
         </p:spPr>
       </p:sp>
     </p:spTree>
@@ -6153,10 +5620,6 @@
           <a:prstGeom prst="rect">
             <a:avLst/>
           </a:prstGeom>
-          <a:noFill/>
-          <a:ln w="0">
-            <a:noFill/>
-          </a:ln>
         </p:spPr>
         <p:txBody>
           <a:bodyPr wrap="square" anchor="t"/>
@@ -6196,10 +5659,6 @@
           <a:prstGeom prst="rect">
             <a:avLst/>
           </a:prstGeom>
-          <a:noFill/>
-          <a:ln w="0">
-            <a:noFill/>
-          </a:ln>
         </p:spPr>
         <p:txBody>
           <a:bodyPr wrap="square" anchor="t"/>
@@ -6267,10 +5726,6 @@
           <a:prstGeom prst="rect">
             <a:avLst/>
           </a:prstGeom>
-          <a:noFill/>
-          <a:ln w="0">
-            <a:noFill/>
-          </a:ln>
         </p:spPr>
         <p:txBody>
           <a:bodyPr wrap="square" anchor="t"/>
@@ -6310,10 +5765,6 @@
           <a:prstGeom prst="rect">
             <a:avLst/>
           </a:prstGeom>
-          <a:noFill/>
-          <a:ln w="0">
-            <a:noFill/>
-          </a:ln>
         </p:spPr>
         <p:txBody>
           <a:bodyPr wrap="square" anchor="t"/>
@@ -6381,10 +5832,6 @@
           <a:prstGeom prst="rect">
             <a:avLst/>
           </a:prstGeom>
-          <a:noFill/>
-          <a:ln w="0">
-            <a:noFill/>
-          </a:ln>
         </p:spPr>
         <p:txBody>
           <a:bodyPr wrap="square" anchor="t"/>
@@ -6424,10 +5871,6 @@
           <a:prstGeom prst="rect">
             <a:avLst/>
           </a:prstGeom>
-          <a:noFill/>
-          <a:ln w="0">
-            <a:noFill/>
-          </a:ln>
         </p:spPr>
         <p:txBody>
           <a:bodyPr wrap="square" anchor="t"/>
@@ -6495,10 +5938,6 @@
           <a:prstGeom prst="rect">
             <a:avLst/>
           </a:prstGeom>
-          <a:noFill/>
-          <a:ln w="0">
-            <a:noFill/>
-          </a:ln>
         </p:spPr>
         <p:txBody>
           <a:bodyPr wrap="square" anchor="t"/>
@@ -6538,10 +5977,6 @@
           <a:prstGeom prst="rect">
             <a:avLst/>
           </a:prstGeom>
-          <a:noFill/>
-          <a:ln w="0">
-            <a:noFill/>
-          </a:ln>
         </p:spPr>
         <p:txBody>
           <a:bodyPr wrap="square" anchor="t"/>
@@ -6609,10 +6044,6 @@
           <a:prstGeom prst="rect">
             <a:avLst/>
           </a:prstGeom>
-          <a:noFill/>
-          <a:ln w="0">
-            <a:noFill/>
-          </a:ln>
         </p:spPr>
         <p:txBody>
           <a:bodyPr wrap="square" anchor="t"/>
@@ -6652,10 +6083,6 @@
           <a:prstGeom prst="rect">
             <a:avLst/>
           </a:prstGeom>
-          <a:noFill/>
-          <a:ln w="0">
-            <a:noFill/>
-          </a:ln>
         </p:spPr>
         <p:txBody>
           <a:bodyPr wrap="square" anchor="t"/>
@@ -6723,10 +6150,6 @@
           <a:prstGeom prst="rect">
             <a:avLst/>
           </a:prstGeom>
-          <a:noFill/>
-          <a:ln w="0">
-            <a:noFill/>
-          </a:ln>
         </p:spPr>
         <p:txBody>
           <a:bodyPr wrap="square" anchor="t"/>
@@ -6766,10 +6189,6 @@
           <a:prstGeom prst="rect">
             <a:avLst/>
           </a:prstGeom>
-          <a:noFill/>
-          <a:ln w="0">
-            <a:noFill/>
-          </a:ln>
         </p:spPr>
         <p:txBody>
           <a:bodyPr wrap="square" anchor="t"/>
@@ -6809,10 +6228,6 @@
           <a:prstGeom prst="rect">
             <a:avLst/>
           </a:prstGeom>
-          <a:noFill/>
-          <a:ln w="0">
-            <a:noFill/>
-          </a:ln>
         </p:spPr>
         <p:txBody>
           <a:bodyPr wrap="square" anchor="t"/>
@@ -6880,10 +6295,6 @@
           <a:prstGeom prst="rect">
             <a:avLst/>
           </a:prstGeom>
-          <a:noFill/>
-          <a:ln w="0">
-            <a:noFill/>
-          </a:ln>
         </p:spPr>
         <p:txBody>
           <a:bodyPr wrap="square" anchor="t"/>
@@ -6923,10 +6334,6 @@
           <a:prstGeom prst="rect">
             <a:avLst/>
           </a:prstGeom>
-          <a:noFill/>
-          <a:ln w="0">
-            <a:noFill/>
-          </a:ln>
         </p:spPr>
         <p:txBody>
           <a:bodyPr wrap="square" anchor="t"/>
@@ -6994,10 +6401,6 @@
           <a:prstGeom prst="rect">
             <a:avLst/>
           </a:prstGeom>
-          <a:noFill/>
-          <a:ln w="0">
-            <a:noFill/>
-          </a:ln>
         </p:spPr>
         <p:txBody>
           <a:bodyPr wrap="square" anchor="t"/>
@@ -7037,10 +6440,6 @@
           <a:prstGeom prst="rect">
             <a:avLst/>
           </a:prstGeom>
-          <a:noFill/>
-          <a:ln w="0">
-            <a:noFill/>
-          </a:ln>
         </p:spPr>
         <p:txBody>
           <a:bodyPr wrap="square" anchor="t"/>
@@ -7108,10 +6507,6 @@
           <a:prstGeom prst="rect">
             <a:avLst/>
           </a:prstGeom>
-          <a:noFill/>
-          <a:ln w="0">
-            <a:noFill/>
-          </a:ln>
         </p:spPr>
         <p:txBody>
           <a:bodyPr wrap="square" anchor="t"/>
@@ -7151,10 +6546,6 @@
           <a:prstGeom prst="rect">
             <a:avLst/>
           </a:prstGeom>
-          <a:noFill/>
-          <a:ln w="0">
-            <a:noFill/>
-          </a:ln>
         </p:spPr>
         <p:txBody>
           <a:bodyPr wrap="square" anchor="t"/>
@@ -7222,10 +6613,6 @@
           <a:prstGeom prst="rect">
             <a:avLst/>
           </a:prstGeom>
-          <a:noFill/>
-          <a:ln w="0">
-            <a:noFill/>
-          </a:ln>
         </p:spPr>
         <p:txBody>
           <a:bodyPr wrap="square" anchor="t"/>
@@ -7265,10 +6652,6 @@
           <a:prstGeom prst="rect">
             <a:avLst/>
           </a:prstGeom>
-          <a:noFill/>
-          <a:ln w="0">
-            <a:noFill/>
-          </a:ln>
         </p:spPr>
         <p:txBody>
           <a:bodyPr wrap="square" anchor="t"/>
@@ -7336,10 +6719,6 @@
           <a:prstGeom prst="rect">
             <a:avLst/>
           </a:prstGeom>
-          <a:noFill/>
-          <a:ln w="0">
-            <a:noFill/>
-          </a:ln>
         </p:spPr>
         <p:txBody>
           <a:bodyPr wrap="square" anchor="t"/>
@@ -7379,10 +6758,6 @@
           <a:prstGeom prst="rect">
             <a:avLst/>
           </a:prstGeom>
-          <a:noFill/>
-          <a:ln w="0">
-            <a:noFill/>
-          </a:ln>
         </p:spPr>
         <p:txBody>
           <a:bodyPr wrap="square" anchor="t"/>
@@ -7422,10 +6797,6 @@
           <a:prstGeom prst="rect">
             <a:avLst/>
           </a:prstGeom>
-          <a:noFill/>
-          <a:ln w="0">
-            <a:noFill/>
-          </a:ln>
         </p:spPr>
         <p:txBody>
           <a:bodyPr wrap="square" anchor="t"/>
@@ -7493,10 +6864,6 @@
           <a:prstGeom prst="rect">
             <a:avLst/>
           </a:prstGeom>
-          <a:noFill/>
-          <a:ln w="0">
-            <a:noFill/>
-          </a:ln>
         </p:spPr>
         <p:txBody>
           <a:bodyPr wrap="square" anchor="t"/>
@@ -7536,10 +6903,6 @@
           <a:prstGeom prst="rect">
             <a:avLst/>
           </a:prstGeom>
-          <a:noFill/>
-          <a:ln w="0">
-            <a:noFill/>
-          </a:ln>
         </p:spPr>
         <p:txBody>
           <a:bodyPr wrap="square" anchor="t"/>
@@ -7579,10 +6942,6 @@
           <a:prstGeom prst="rect">
             <a:avLst/>
           </a:prstGeom>
-          <a:noFill/>
-          <a:ln w="0">
-            <a:noFill/>
-          </a:ln>
         </p:spPr>
         <p:txBody>
           <a:bodyPr wrap="square" anchor="t"/>
@@ -7650,10 +7009,6 @@
           <a:prstGeom prst="rect">
             <a:avLst/>
           </a:prstGeom>
-          <a:noFill/>
-          <a:ln w="0">
-            <a:noFill/>
-          </a:ln>
         </p:spPr>
         <p:txBody>
           <a:bodyPr wrap="square" anchor="t"/>
@@ -7693,10 +7048,6 @@
           <a:prstGeom prst="rect">
             <a:avLst/>
           </a:prstGeom>
-          <a:noFill/>
-          <a:ln w="0">
-            <a:noFill/>
-          </a:ln>
         </p:spPr>
         <p:txBody>
           <a:bodyPr wrap="square" anchor="t"/>
@@ -7736,10 +7087,6 @@
           <a:prstGeom prst="rect">
             <a:avLst/>
           </a:prstGeom>
-          <a:noFill/>
-          <a:ln w="0">
-            <a:noFill/>
-          </a:ln>
         </p:spPr>
         <p:txBody>
           <a:bodyPr wrap="square" anchor="t"/>
@@ -7807,10 +7154,6 @@
           <a:prstGeom prst="rect">
             <a:avLst/>
           </a:prstGeom>
-          <a:noFill/>
-          <a:ln w="0">
-            <a:noFill/>
-          </a:ln>
         </p:spPr>
         <p:txBody>
           <a:bodyPr wrap="square" anchor="t"/>
@@ -7850,10 +7193,6 @@
           <a:prstGeom prst="rect">
             <a:avLst/>
           </a:prstGeom>
-          <a:noFill/>
-          <a:ln w="0">
-            <a:noFill/>
-          </a:ln>
         </p:spPr>
         <p:txBody>
           <a:bodyPr wrap="square" anchor="t"/>
@@ -7893,10 +7232,6 @@
           <a:prstGeom prst="rect">
             <a:avLst/>
           </a:prstGeom>
-          <a:noFill/>
-          <a:ln w="0">
-            <a:noFill/>
-          </a:ln>
         </p:spPr>
         <p:txBody>
           <a:bodyPr wrap="square" anchor="t"/>
@@ -7936,10 +7271,6 @@
           <a:prstGeom prst="rect">
             <a:avLst/>
           </a:prstGeom>
-          <a:noFill/>
-          <a:ln w="0">
-            <a:noFill/>
-          </a:ln>
         </p:spPr>
         <p:txBody>
           <a:bodyPr wrap="square" anchor="t"/>
@@ -8007,10 +7338,6 @@
           <a:prstGeom prst="rect">
             <a:avLst/>
           </a:prstGeom>
-          <a:noFill/>
-          <a:ln w="0">
-            <a:noFill/>
-          </a:ln>
         </p:spPr>
         <p:txBody>
           <a:bodyPr wrap="square" anchor="t"/>
@@ -8050,10 +7377,6 @@
           <a:prstGeom prst="rect">
             <a:avLst/>
           </a:prstGeom>
-          <a:noFill/>
-          <a:ln w="0">
-            <a:noFill/>
-          </a:ln>
         </p:spPr>
         <p:txBody>
           <a:bodyPr wrap="square" anchor="t"/>
@@ -8093,10 +7416,6 @@
           <a:prstGeom prst="rect">
             <a:avLst/>
           </a:prstGeom>
-          <a:noFill/>
-          <a:ln w="0">
-            <a:noFill/>
-          </a:ln>
         </p:spPr>
         <p:txBody>
           <a:bodyPr wrap="square" anchor="t"/>
@@ -8136,10 +7455,6 @@
           <a:prstGeom prst="rect">
             <a:avLst/>
           </a:prstGeom>
-          <a:noFill/>
-          <a:ln w="0">
-            <a:noFill/>
-          </a:ln>
         </p:spPr>
         <p:txBody>
           <a:bodyPr wrap="square" anchor="t"/>
@@ -8179,10 +7494,6 @@
           <a:prstGeom prst="rect">
             <a:avLst/>
           </a:prstGeom>
-          <a:noFill/>
-          <a:ln w="0">
-            <a:noFill/>
-          </a:ln>
         </p:spPr>
         <p:txBody>
           <a:bodyPr wrap="square" anchor="t"/>
@@ -8222,10 +7533,6 @@
           <a:prstGeom prst="rect">
             <a:avLst/>
           </a:prstGeom>
-          <a:noFill/>
-          <a:ln w="0">
-            <a:noFill/>
-          </a:ln>
         </p:spPr>
         <p:txBody>
           <a:bodyPr wrap="square" anchor="t"/>
@@ -8265,10 +7572,6 @@
           <a:prstGeom prst="rect">
             <a:avLst/>
           </a:prstGeom>
-          <a:noFill/>
-          <a:ln w="0">
-            <a:noFill/>
-          </a:ln>
         </p:spPr>
         <p:txBody>
           <a:bodyPr wrap="square" anchor="t"/>

</xml_diff>